<commit_message>
Replace baseline policy with corrected Phase 95 selection
</commit_message>
<xml_diff>
--- a/paper/figures/objective-locations-schematic/objective-locations-schematic.pptx
+++ b/paper/figures/objective-locations-schematic/objective-locations-schematic.pptx
@@ -208,7 +208,7 @@
           <a:p>
             <a:fld id="{92497D44-5EFE-4F9A-A795-905516EB024A}" type="datetimeFigureOut">
               <a:rPr lang="en-US" smtClean="0"/>
-              <a:t>9/11/2026</a:t>
+              <a:t>9/23/2026</a:t>
             </a:fld>
             <a:endParaRPr lang="en-US"/>
           </a:p>
@@ -606,7 +606,7 @@
           <a:p>
             <a:fld id="{094C9CC1-EEE0-4B4B-ACEA-60EB0E46BF88}" type="datetimeFigureOut">
               <a:rPr lang="en-US" smtClean="0"/>
-              <a:t>9/11/2026</a:t>
+              <a:t>9/23/2026</a:t>
             </a:fld>
             <a:endParaRPr lang="en-US"/>
           </a:p>
@@ -776,7 +776,7 @@
           <a:p>
             <a:fld id="{094C9CC1-EEE0-4B4B-ACEA-60EB0E46BF88}" type="datetimeFigureOut">
               <a:rPr lang="en-US" smtClean="0"/>
-              <a:t>9/11/2026</a:t>
+              <a:t>9/23/2026</a:t>
             </a:fld>
             <a:endParaRPr lang="en-US"/>
           </a:p>
@@ -956,7 +956,7 @@
           <a:p>
             <a:fld id="{094C9CC1-EEE0-4B4B-ACEA-60EB0E46BF88}" type="datetimeFigureOut">
               <a:rPr lang="en-US" smtClean="0"/>
-              <a:t>9/11/2026</a:t>
+              <a:t>9/23/2026</a:t>
             </a:fld>
             <a:endParaRPr lang="en-US"/>
           </a:p>
@@ -1126,7 +1126,7 @@
           <a:p>
             <a:fld id="{094C9CC1-EEE0-4B4B-ACEA-60EB0E46BF88}" type="datetimeFigureOut">
               <a:rPr lang="en-US" smtClean="0"/>
-              <a:t>9/11/2026</a:t>
+              <a:t>9/23/2026</a:t>
             </a:fld>
             <a:endParaRPr lang="en-US"/>
           </a:p>
@@ -1372,7 +1372,7 @@
           <a:p>
             <a:fld id="{094C9CC1-EEE0-4B4B-ACEA-60EB0E46BF88}" type="datetimeFigureOut">
               <a:rPr lang="en-US" smtClean="0"/>
-              <a:t>9/11/2026</a:t>
+              <a:t>9/23/2026</a:t>
             </a:fld>
             <a:endParaRPr lang="en-US"/>
           </a:p>
@@ -1604,7 +1604,7 @@
           <a:p>
             <a:fld id="{094C9CC1-EEE0-4B4B-ACEA-60EB0E46BF88}" type="datetimeFigureOut">
               <a:rPr lang="en-US" smtClean="0"/>
-              <a:t>9/11/2026</a:t>
+              <a:t>9/23/2026</a:t>
             </a:fld>
             <a:endParaRPr lang="en-US"/>
           </a:p>
@@ -1971,7 +1971,7 @@
           <a:p>
             <a:fld id="{094C9CC1-EEE0-4B4B-ACEA-60EB0E46BF88}" type="datetimeFigureOut">
               <a:rPr lang="en-US" smtClean="0"/>
-              <a:t>9/11/2026</a:t>
+              <a:t>9/23/2026</a:t>
             </a:fld>
             <a:endParaRPr lang="en-US"/>
           </a:p>
@@ -2089,7 +2089,7 @@
           <a:p>
             <a:fld id="{094C9CC1-EEE0-4B4B-ACEA-60EB0E46BF88}" type="datetimeFigureOut">
               <a:rPr lang="en-US" smtClean="0"/>
-              <a:t>9/11/2026</a:t>
+              <a:t>9/23/2026</a:t>
             </a:fld>
             <a:endParaRPr lang="en-US"/>
           </a:p>
@@ -2184,7 +2184,7 @@
           <a:p>
             <a:fld id="{094C9CC1-EEE0-4B4B-ACEA-60EB0E46BF88}" type="datetimeFigureOut">
               <a:rPr lang="en-US" smtClean="0"/>
-              <a:t>9/11/2026</a:t>
+              <a:t>9/23/2026</a:t>
             </a:fld>
             <a:endParaRPr lang="en-US"/>
           </a:p>
@@ -2461,7 +2461,7 @@
           <a:p>
             <a:fld id="{094C9CC1-EEE0-4B4B-ACEA-60EB0E46BF88}" type="datetimeFigureOut">
               <a:rPr lang="en-US" smtClean="0"/>
-              <a:t>9/11/2026</a:t>
+              <a:t>9/23/2026</a:t>
             </a:fld>
             <a:endParaRPr lang="en-US"/>
           </a:p>
@@ -2718,7 +2718,7 @@
           <a:p>
             <a:fld id="{094C9CC1-EEE0-4B4B-ACEA-60EB0E46BF88}" type="datetimeFigureOut">
               <a:rPr lang="en-US" smtClean="0"/>
-              <a:t>9/11/2026</a:t>
+              <a:t>9/23/2026</a:t>
             </a:fld>
             <a:endParaRPr lang="en-US"/>
           </a:p>
@@ -2931,7 +2931,7 @@
           <a:p>
             <a:fld id="{094C9CC1-EEE0-4B4B-ACEA-60EB0E46BF88}" type="datetimeFigureOut">
               <a:rPr lang="en-US" smtClean="0"/>
-              <a:t>9/11/2026</a:t>
+              <a:t>9/23/2026</a:t>
             </a:fld>
             <a:endParaRPr lang="en-US"/>
           </a:p>
@@ -5301,42 +5301,39 @@
             <a:p>
               <a:pPr algn="ctr"/>
               <a:r>
-                <a:rPr lang="en-US" sz="1100" b="1" dirty="0">
+                <a:rPr lang="en-US" sz="1100" b="1">
                   <a:solidFill>
                     <a:srgbClr val="111827"/>
                   </a:solidFill>
                   <a:latin typeface="Inter"/>
                 </a:rPr>
-                <a:t>Meet annual NIIP</a:t>
+                <a:t>Match historic NIIP</a:t>
               </a:r>
             </a:p>
             <a:p>
               <a:pPr algn="ctr"/>
               <a:r>
-                <a:rPr lang="en-US" sz="1100" b="1" dirty="0">
+                <a:rPr lang="en-US" sz="1100" b="1">
                   <a:solidFill>
                     <a:srgbClr val="111827"/>
                   </a:solidFill>
                   <a:latin typeface="Inter"/>
                 </a:rPr>
-                <a:t>delivery volume</a:t>
+                <a:t>delivery proxy</a:t>
               </a:r>
             </a:p>
             <a:p>
               <a:pPr algn="ctr"/>
               <a:r>
-                <a:rPr lang="en-US" sz="1100" dirty="0">
+                <a:rPr lang="en-US" sz="1000">
                   <a:solidFill>
                     <a:srgbClr val="111827"/>
                   </a:solidFill>
                   <a:latin typeface="Inter"/>
                 </a:rPr>
-                <a:t>Annual volume / obligation ≥ 100%</a:t>
+                <a:t>Complete-season delivery / proxy ≥ 100%</a:t>
               </a:r>
-            </a:p>
-            <a:p>
-              <a:pPr algn="ctr"/>
-              <a:endParaRPr lang="en-US" sz="1100" dirty="0">
+              <a:endParaRPr lang="en-US" sz="1000" dirty="0">
                 <a:solidFill>
                   <a:srgbClr val="111827"/>
                 </a:solidFill>

</xml_diff>